<commit_message>
Add Infinity Nexus logo, AUC as %, Low-Risk SMS metric, updated PPT numbers
</commit_message>
<xml_diff>
--- a/Hackathon_project/Clinical_NoShow_Prediction.pptx
+++ b/Hackathon_project/Clinical_NoShow_Prediction.pptx
@@ -3995,17 +3995,17 @@
             <a:br/>
             <a:br/>
             <a:r>
-              <a:t>📉 Predicted No-Shows: ~35</a:t>
+              <a:t>📉 Predicted No-Shows: ~43</a:t>
             </a:r>
             <a:br/>
             <a:br/>
             <a:r>
-              <a:t>❌ Estimated Loss: $8,750+</a:t>
+              <a:t>❌ Estimated Loss: $10,710</a:t>
             </a:r>
             <a:br/>
             <a:br/>
             <a:r>
-              <a:t>⚠️ Based on 594 upcoming</a:t>
+              <a:t>⚠️ Based on 587 upcoming</a:t>
             </a:r>
             <a:br/>
             <a:r>
@@ -4082,7 +4082,7 @@
             <a:br/>
             <a:br/>
             <a:r>
-              <a:t>✅ Recoverable Revenue: ~$2,500+</a:t>
+              <a:t>✅ Recoverable Revenue: ~$4,280+</a:t>
             </a:r>
             <a:br/>
             <a:br/>
@@ -5224,7 +5224,7 @@
             </a:r>
             <a:br/>
             <a:r>
-              <a:t>trained on 4,800+</a:t>
+              <a:t>trained on 4,804</a:t>
             </a:r>
             <a:br/>
             <a:r>
@@ -5233,7 +5233,7 @@
             <a:br/>
             <a:br/>
             <a:r>
-              <a:t>AUC &gt; 0.55</a:t>
+              <a:t>AUC: 60.4%</a:t>
             </a:r>
           </a:p>
         </p:txBody>
@@ -6345,7 +6345,7 @@
               </a:defRPr>
             </a:pPr>
             <a:r>
-              <a:t>🔗  Join: Left merge on patient_id → 4,800+ enriched records</a:t>
+              <a:t>🔗  Join: Left merge on patient_id → 4,804 enriched records</a:t>
             </a:r>
           </a:p>
           <a:p>
@@ -6489,7 +6489,7 @@
               </a:defRPr>
             </a:pPr>
             <a:r>
-              <a:t>Training Data: 4,800+ historical in-person appointments</a:t>
+              <a:t>Training Data: 4,804 historical in-person appointments</a:t>
             </a:r>
           </a:p>
           <a:p>

</xml_diff>